<commit_message>
new labs added and changes made
</commit_message>
<xml_diff>
--- a/PPT_370_EmergingTechnologies.pptx
+++ b/PPT_370_EmergingTechnologies.pptx
@@ -158,7 +158,7 @@
 <file path=ppt/revisionInfo.xml><?xml version="1.0" encoding="utf-8"?>
 <p1510:revInfo xmlns:a="http://schemas.openxmlformats.org/drawingml/2006/main" xmlns:r="http://schemas.openxmlformats.org/officeDocument/2006/relationships" xmlns:p1510="http://schemas.microsoft.com/office/powerpoint/2015/10/main">
   <p1510:revLst>
-    <p1510:client id="{C839E10A-5450-46C1-8B96-290942955DEC}" v="45" dt="2026-08-27T07:59:04.602"/>
+    <p1510:client id="{C839E10A-5450-46C1-8B96-290942955DEC}" v="51" dt="2026-09-17T07:56:03.594"/>
   </p1510:revLst>
 </p1510:revInfo>
 </file>
@@ -167,13 +167,13 @@
 <pc:chgInfo xmlns:a="http://schemas.openxmlformats.org/drawingml/2006/main" xmlns:r="http://schemas.openxmlformats.org/officeDocument/2006/relationships" xmlns:ac="http://schemas.microsoft.com/office/drawing/2013/main/command" xmlns:pc="http://schemas.microsoft.com/office/powerpoint/2013/main/command">
   <pc:docChgLst>
     <pc:chgData name="Shreena Solia" userId="ce99177b26c586f9" providerId="LiveId" clId="{1F1047B7-353E-4D5F-BD1C-2AC2A6DBBBA4}"/>
-    <pc:docChg chg="custSel addSld delSld modSld sldOrd">
-      <pc:chgData name="Shreena Solia" userId="ce99177b26c586f9" providerId="LiveId" clId="{1F1047B7-353E-4D5F-BD1C-2AC2A6DBBBA4}" dt="2026-09-01T09:51:02.294" v="474" actId="27636"/>
+    <pc:docChg chg="custSel addSld delSld modSld sldOrd modMainMaster">
+      <pc:chgData name="Shreena Solia" userId="ce99177b26c586f9" providerId="LiveId" clId="{1F1047B7-353E-4D5F-BD1C-2AC2A6DBBBA4}" dt="2026-09-17T07:56:03.593" v="480"/>
       <pc:docMkLst>
         <pc:docMk/>
       </pc:docMkLst>
-      <pc:sldChg chg="addSp delSp modSp mod">
-        <pc:chgData name="Shreena Solia" userId="ce99177b26c586f9" providerId="LiveId" clId="{1F1047B7-353E-4D5F-BD1C-2AC2A6DBBBA4}" dt="2026-08-27T08:00:55.387" v="443" actId="931"/>
+      <pc:sldChg chg="addSp delSp modSp mod modTransition">
+        <pc:chgData name="Shreena Solia" userId="ce99177b26c586f9" providerId="LiveId" clId="{1F1047B7-353E-4D5F-BD1C-2AC2A6DBBBA4}" dt="2026-09-17T07:56:03.593" v="480"/>
         <pc:sldMkLst>
           <pc:docMk/>
           <pc:sldMk cId="1593920805" sldId="262"/>
@@ -203,8 +203,8 @@
           </ac:picMkLst>
         </pc:picChg>
       </pc:sldChg>
-      <pc:sldChg chg="modSp mod">
-        <pc:chgData name="Shreena Solia" userId="ce99177b26c586f9" providerId="LiveId" clId="{1F1047B7-353E-4D5F-BD1C-2AC2A6DBBBA4}" dt="2026-08-27T07:33:05.633" v="87" actId="113"/>
+      <pc:sldChg chg="modSp mod modTransition">
+        <pc:chgData name="Shreena Solia" userId="ce99177b26c586f9" providerId="LiveId" clId="{1F1047B7-353E-4D5F-BD1C-2AC2A6DBBBA4}" dt="2026-09-17T07:56:03.593" v="480"/>
         <pc:sldMkLst>
           <pc:docMk/>
           <pc:sldMk cId="3650340329" sldId="264"/>
@@ -218,8 +218,8 @@
           </ac:spMkLst>
         </pc:spChg>
       </pc:sldChg>
-      <pc:sldChg chg="modSp mod">
-        <pc:chgData name="Shreena Solia" userId="ce99177b26c586f9" providerId="LiveId" clId="{1F1047B7-353E-4D5F-BD1C-2AC2A6DBBBA4}" dt="2026-08-27T07:38:16.967" v="139" actId="1076"/>
+      <pc:sldChg chg="modSp mod modTransition">
+        <pc:chgData name="Shreena Solia" userId="ce99177b26c586f9" providerId="LiveId" clId="{1F1047B7-353E-4D5F-BD1C-2AC2A6DBBBA4}" dt="2026-09-17T07:56:03.593" v="480"/>
         <pc:sldMkLst>
           <pc:docMk/>
           <pc:sldMk cId="920173932" sldId="275"/>
@@ -241,8 +241,8 @@
           </ac:spMkLst>
         </pc:spChg>
       </pc:sldChg>
-      <pc:sldChg chg="addSp delSp modSp mod">
-        <pc:chgData name="Shreena Solia" userId="ce99177b26c586f9" providerId="LiveId" clId="{1F1047B7-353E-4D5F-BD1C-2AC2A6DBBBA4}" dt="2026-08-27T07:30:23.015" v="78" actId="1076"/>
+      <pc:sldChg chg="addSp delSp modSp mod modTransition">
+        <pc:chgData name="Shreena Solia" userId="ce99177b26c586f9" providerId="LiveId" clId="{1F1047B7-353E-4D5F-BD1C-2AC2A6DBBBA4}" dt="2026-09-17T07:56:03.593" v="480"/>
         <pc:sldMkLst>
           <pc:docMk/>
           <pc:sldMk cId="2243494996" sldId="277"/>
@@ -272,8 +272,8 @@
           </ac:picMkLst>
         </pc:picChg>
       </pc:sldChg>
-      <pc:sldChg chg="modSp mod">
-        <pc:chgData name="Shreena Solia" userId="ce99177b26c586f9" providerId="LiveId" clId="{1F1047B7-353E-4D5F-BD1C-2AC2A6DBBBA4}" dt="2026-09-01T09:48:42.800" v="450" actId="6549"/>
+      <pc:sldChg chg="modSp mod modTransition">
+        <pc:chgData name="Shreena Solia" userId="ce99177b26c586f9" providerId="LiveId" clId="{1F1047B7-353E-4D5F-BD1C-2AC2A6DBBBA4}" dt="2026-09-17T07:56:03.593" v="480"/>
         <pc:sldMkLst>
           <pc:docMk/>
           <pc:sldMk cId="4151694508" sldId="286"/>
@@ -303,8 +303,8 @@
           </ac:spMkLst>
         </pc:spChg>
       </pc:sldChg>
-      <pc:sldChg chg="addSp delSp modSp mod">
-        <pc:chgData name="Shreena Solia" userId="ce99177b26c586f9" providerId="LiveId" clId="{1F1047B7-353E-4D5F-BD1C-2AC2A6DBBBA4}" dt="2026-08-27T07:54:09.764" v="343" actId="1076"/>
+      <pc:sldChg chg="addSp delSp modSp mod modTransition">
+        <pc:chgData name="Shreena Solia" userId="ce99177b26c586f9" providerId="LiveId" clId="{1F1047B7-353E-4D5F-BD1C-2AC2A6DBBBA4}" dt="2026-09-17T07:56:03.593" v="480"/>
         <pc:sldMkLst>
           <pc:docMk/>
           <pc:sldMk cId="1472106130" sldId="288"/>
@@ -326,15 +326,8 @@
           </ac:spMkLst>
         </pc:spChg>
       </pc:sldChg>
-      <pc:sldChg chg="del ord">
-        <pc:chgData name="Shreena Solia" userId="ce99177b26c586f9" providerId="LiveId" clId="{1F1047B7-353E-4D5F-BD1C-2AC2A6DBBBA4}" dt="2026-09-01T09:50:37.139" v="465" actId="2696"/>
-        <pc:sldMkLst>
-          <pc:docMk/>
-          <pc:sldMk cId="2561631246" sldId="289"/>
-        </pc:sldMkLst>
-      </pc:sldChg>
-      <pc:sldChg chg="addSp modSp mod">
-        <pc:chgData name="Shreena Solia" userId="ce99177b26c586f9" providerId="LiveId" clId="{1F1047B7-353E-4D5F-BD1C-2AC2A6DBBBA4}" dt="2026-08-27T07:48:50.325" v="288" actId="1076"/>
+      <pc:sldChg chg="addSp modSp mod modTransition">
+        <pc:chgData name="Shreena Solia" userId="ce99177b26c586f9" providerId="LiveId" clId="{1F1047B7-353E-4D5F-BD1C-2AC2A6DBBBA4}" dt="2026-09-17T07:56:03.593" v="480"/>
         <pc:sldMkLst>
           <pc:docMk/>
           <pc:sldMk cId="2436493926" sldId="293"/>
@@ -364,8 +357,8 @@
           </ac:picMkLst>
         </pc:picChg>
       </pc:sldChg>
-      <pc:sldChg chg="modSp mod">
-        <pc:chgData name="Shreena Solia" userId="ce99177b26c586f9" providerId="LiveId" clId="{1F1047B7-353E-4D5F-BD1C-2AC2A6DBBBA4}" dt="2026-09-01T09:51:02.294" v="474" actId="27636"/>
+      <pc:sldChg chg="modSp mod modTransition">
+        <pc:chgData name="Shreena Solia" userId="ce99177b26c586f9" providerId="LiveId" clId="{1F1047B7-353E-4D5F-BD1C-2AC2A6DBBBA4}" dt="2026-09-17T07:56:03.593" v="480"/>
         <pc:sldMkLst>
           <pc:docMk/>
           <pc:sldMk cId="2578554952" sldId="294"/>
@@ -395,8 +388,8 @@
           </ac:spMkLst>
         </pc:spChg>
       </pc:sldChg>
-      <pc:sldChg chg="addSp delSp modSp mod">
-        <pc:chgData name="Shreena Solia" userId="ce99177b26c586f9" providerId="LiveId" clId="{1F1047B7-353E-4D5F-BD1C-2AC2A6DBBBA4}" dt="2026-09-01T09:50:47.158" v="469" actId="478"/>
+      <pc:sldChg chg="addSp delSp modSp mod modTransition">
+        <pc:chgData name="Shreena Solia" userId="ce99177b26c586f9" providerId="LiveId" clId="{1F1047B7-353E-4D5F-BD1C-2AC2A6DBBBA4}" dt="2026-09-17T07:56:03.593" v="480"/>
         <pc:sldMkLst>
           <pc:docMk/>
           <pc:sldMk cId="3830685312" sldId="295"/>
@@ -425,53 +418,16 @@
             <ac:spMk id="6" creationId="{5A6B31B0-7B84-475D-961F-09C0191F91A2}"/>
           </ac:spMkLst>
         </pc:spChg>
-        <pc:graphicFrameChg chg="del modGraphic">
-          <ac:chgData name="Shreena Solia" userId="ce99177b26c586f9" providerId="LiveId" clId="{1F1047B7-353E-4D5F-BD1C-2AC2A6DBBBA4}" dt="2026-09-01T09:50:47.158" v="469" actId="478"/>
-          <ac:graphicFrameMkLst>
-            <pc:docMk/>
-            <pc:sldMk cId="3830685312" sldId="295"/>
-            <ac:graphicFrameMk id="7" creationId="{2B3209A9-DBA3-783A-240E-673257FE1112}"/>
-          </ac:graphicFrameMkLst>
-        </pc:graphicFrameChg>
       </pc:sldChg>
-      <pc:sldChg chg="del">
-        <pc:chgData name="Shreena Solia" userId="ce99177b26c586f9" providerId="LiveId" clId="{1F1047B7-353E-4D5F-BD1C-2AC2A6DBBBA4}" dt="2026-09-01T09:50:32.326" v="464" actId="2696"/>
+      <pc:sldChg chg="modTransition">
+        <pc:chgData name="Shreena Solia" userId="ce99177b26c586f9" providerId="LiveId" clId="{1F1047B7-353E-4D5F-BD1C-2AC2A6DBBBA4}" dt="2026-09-17T07:56:03.593" v="480"/>
         <pc:sldMkLst>
           <pc:docMk/>
-          <pc:sldMk cId="1013586251" sldId="299"/>
+          <pc:sldMk cId="1711019939" sldId="298"/>
         </pc:sldMkLst>
       </pc:sldChg>
-      <pc:sldChg chg="modSp del mod">
-        <pc:chgData name="Shreena Solia" userId="ce99177b26c586f9" providerId="LiveId" clId="{1F1047B7-353E-4D5F-BD1C-2AC2A6DBBBA4}" dt="2026-09-01T09:50:00.230" v="455" actId="2696"/>
-        <pc:sldMkLst>
-          <pc:docMk/>
-          <pc:sldMk cId="1730481778" sldId="300"/>
-        </pc:sldMkLst>
-        <pc:spChg chg="mod">
-          <ac:chgData name="Shreena Solia" userId="ce99177b26c586f9" providerId="LiveId" clId="{1F1047B7-353E-4D5F-BD1C-2AC2A6DBBBA4}" dt="2026-09-01T09:49:56.301" v="454" actId="6549"/>
-          <ac:spMkLst>
-            <pc:docMk/>
-            <pc:sldMk cId="1730481778" sldId="300"/>
-            <ac:spMk id="4" creationId="{EFC8EEE6-5FB5-798B-7D00-0CDE54C241BB}"/>
-          </ac:spMkLst>
-        </pc:spChg>
-      </pc:sldChg>
-      <pc:sldChg chg="del">
-        <pc:chgData name="Shreena Solia" userId="ce99177b26c586f9" providerId="LiveId" clId="{1F1047B7-353E-4D5F-BD1C-2AC2A6DBBBA4}" dt="2026-09-01T09:50:16.913" v="461" actId="2696"/>
-        <pc:sldMkLst>
-          <pc:docMk/>
-          <pc:sldMk cId="3905068818" sldId="301"/>
-        </pc:sldMkLst>
-      </pc:sldChg>
-      <pc:sldChg chg="del">
-        <pc:chgData name="Shreena Solia" userId="ce99177b26c586f9" providerId="LiveId" clId="{1F1047B7-353E-4D5F-BD1C-2AC2A6DBBBA4}" dt="2026-09-01T09:50:52.862" v="470" actId="2696"/>
-        <pc:sldMkLst>
-          <pc:docMk/>
-          <pc:sldMk cId="325392634" sldId="302"/>
-        </pc:sldMkLst>
-      </pc:sldChg>
-      <pc:sldChg chg="modSp add mod ord">
-        <pc:chgData name="Shreena Solia" userId="ce99177b26c586f9" providerId="LiveId" clId="{1F1047B7-353E-4D5F-BD1C-2AC2A6DBBBA4}" dt="2026-09-01T09:50:12.202" v="460" actId="6549"/>
+      <pc:sldChg chg="modSp add mod ord modTransition">
+        <pc:chgData name="Shreena Solia" userId="ce99177b26c586f9" providerId="LiveId" clId="{1F1047B7-353E-4D5F-BD1C-2AC2A6DBBBA4}" dt="2026-09-17T07:56:03.593" v="480"/>
         <pc:sldMkLst>
           <pc:docMk/>
           <pc:sldMk cId="1120807269" sldId="303"/>
@@ -493,8 +449,8 @@
           </ac:spMkLst>
         </pc:spChg>
       </pc:sldChg>
-      <pc:sldChg chg="addSp delSp modSp add mod ord">
-        <pc:chgData name="Shreena Solia" userId="ce99177b26c586f9" providerId="LiveId" clId="{1F1047B7-353E-4D5F-BD1C-2AC2A6DBBBA4}" dt="2026-09-01T09:48:57.575" v="453" actId="478"/>
+      <pc:sldChg chg="addSp delSp modSp add mod ord modTransition">
+        <pc:chgData name="Shreena Solia" userId="ce99177b26c586f9" providerId="LiveId" clId="{1F1047B7-353E-4D5F-BD1C-2AC2A6DBBBA4}" dt="2026-09-17T07:56:03.593" v="480"/>
         <pc:sldMkLst>
           <pc:docMk/>
           <pc:sldMk cId="1034298867" sldId="304"/>
@@ -523,29 +479,13 @@
             <ac:spMk id="6" creationId="{4A356FF8-8CA8-8C48-C00C-E4F86208AE74}"/>
           </ac:spMkLst>
         </pc:spChg>
-        <pc:graphicFrameChg chg="del">
-          <ac:chgData name="Shreena Solia" userId="ce99177b26c586f9" providerId="LiveId" clId="{1F1047B7-353E-4D5F-BD1C-2AC2A6DBBBA4}" dt="2026-09-01T09:48:57.575" v="453" actId="478"/>
-          <ac:graphicFrameMkLst>
-            <pc:docMk/>
-            <pc:sldMk cId="1034298867" sldId="304"/>
-            <ac:graphicFrameMk id="10" creationId="{3F69DD36-A862-369C-72F9-D874D7880BB5}"/>
-          </ac:graphicFrameMkLst>
-        </pc:graphicFrameChg>
       </pc:sldChg>
-      <pc:sldChg chg="addSp delSp modSp add mod ord">
-        <pc:chgData name="Shreena Solia" userId="ce99177b26c586f9" providerId="LiveId" clId="{1F1047B7-353E-4D5F-BD1C-2AC2A6DBBBA4}" dt="2026-09-01T09:50:26.640" v="463" actId="478"/>
+      <pc:sldChg chg="addSp delSp modSp add mod ord modTransition">
+        <pc:chgData name="Shreena Solia" userId="ce99177b26c586f9" providerId="LiveId" clId="{1F1047B7-353E-4D5F-BD1C-2AC2A6DBBBA4}" dt="2026-09-17T07:56:03.593" v="480"/>
         <pc:sldMkLst>
           <pc:docMk/>
           <pc:sldMk cId="1800142194" sldId="305"/>
         </pc:sldMkLst>
-        <pc:spChg chg="del mod">
-          <ac:chgData name="Shreena Solia" userId="ce99177b26c586f9" providerId="LiveId" clId="{1F1047B7-353E-4D5F-BD1C-2AC2A6DBBBA4}" dt="2026-09-01T09:50:26.640" v="463" actId="478"/>
-          <ac:spMkLst>
-            <pc:docMk/>
-            <pc:sldMk cId="1800142194" sldId="305"/>
-            <ac:spMk id="2" creationId="{E713F115-1AA2-D508-9D4A-92C9B4B66AAA}"/>
-          </ac:spMkLst>
-        </pc:spChg>
         <pc:spChg chg="add mod">
           <ac:chgData name="Shreena Solia" userId="ce99177b26c586f9" providerId="LiveId" clId="{1F1047B7-353E-4D5F-BD1C-2AC2A6DBBBA4}" dt="2026-09-01T09:50:26.640" v="463" actId="478"/>
           <ac:spMkLst>
@@ -562,23 +502,118 @@
             <ac:spMk id="6" creationId="{4EC5940D-2553-0022-B5BF-B93CC11A234C}"/>
           </ac:spMkLst>
         </pc:spChg>
-        <pc:picChg chg="del">
-          <ac:chgData name="Shreena Solia" userId="ce99177b26c586f9" providerId="LiveId" clId="{1F1047B7-353E-4D5F-BD1C-2AC2A6DBBBA4}" dt="2026-09-01T09:50:26.640" v="463" actId="478"/>
-          <ac:picMkLst>
+      </pc:sldChg>
+      <pc:sldMasterChg chg="modTransition modSldLayout">
+        <pc:chgData name="Shreena Solia" userId="ce99177b26c586f9" providerId="LiveId" clId="{1F1047B7-353E-4D5F-BD1C-2AC2A6DBBBA4}" dt="2026-09-17T07:56:03.593" v="480"/>
+        <pc:sldMasterMkLst>
+          <pc:docMk/>
+          <pc:sldMasterMk cId="1544047913" sldId="2147483660"/>
+        </pc:sldMasterMkLst>
+        <pc:sldLayoutChg chg="modTransition">
+          <pc:chgData name="Shreena Solia" userId="ce99177b26c586f9" providerId="LiveId" clId="{1F1047B7-353E-4D5F-BD1C-2AC2A6DBBBA4}" dt="2026-09-17T07:56:03.593" v="480"/>
+          <pc:sldLayoutMkLst>
             <pc:docMk/>
-            <pc:sldMk cId="1800142194" sldId="305"/>
-            <ac:picMk id="13" creationId="{86546C17-130D-B615-F9B4-590758216477}"/>
-          </ac:picMkLst>
-        </pc:picChg>
-        <pc:picChg chg="del">
-          <ac:chgData name="Shreena Solia" userId="ce99177b26c586f9" providerId="LiveId" clId="{1F1047B7-353E-4D5F-BD1C-2AC2A6DBBBA4}" dt="2026-09-01T09:50:26.640" v="463" actId="478"/>
-          <ac:picMkLst>
+            <pc:sldMasterMk cId="1544047913" sldId="2147483660"/>
+            <pc:sldLayoutMk cId="4196340225" sldId="2147483663"/>
+          </pc:sldLayoutMkLst>
+        </pc:sldLayoutChg>
+        <pc:sldLayoutChg chg="modTransition">
+          <pc:chgData name="Shreena Solia" userId="ce99177b26c586f9" providerId="LiveId" clId="{1F1047B7-353E-4D5F-BD1C-2AC2A6DBBBA4}" dt="2026-09-17T07:56:03.593" v="480"/>
+          <pc:sldLayoutMkLst>
             <pc:docMk/>
-            <pc:sldMk cId="1800142194" sldId="305"/>
-            <ac:picMk id="21" creationId="{BA7C1292-7C12-5D7E-FE34-64DB4E522F53}"/>
-          </ac:picMkLst>
-        </pc:picChg>
-      </pc:sldChg>
+            <pc:sldMasterMk cId="1544047913" sldId="2147483660"/>
+            <pc:sldLayoutMk cId="355283013" sldId="2147483665"/>
+          </pc:sldLayoutMkLst>
+        </pc:sldLayoutChg>
+        <pc:sldLayoutChg chg="modTransition">
+          <pc:chgData name="Shreena Solia" userId="ce99177b26c586f9" providerId="LiveId" clId="{1F1047B7-353E-4D5F-BD1C-2AC2A6DBBBA4}" dt="2026-09-17T07:56:03.593" v="480"/>
+          <pc:sldLayoutMkLst>
+            <pc:docMk/>
+            <pc:sldMasterMk cId="1544047913" sldId="2147483660"/>
+            <pc:sldLayoutMk cId="1563524165" sldId="2147483679"/>
+          </pc:sldLayoutMkLst>
+        </pc:sldLayoutChg>
+        <pc:sldLayoutChg chg="modTransition">
+          <pc:chgData name="Shreena Solia" userId="ce99177b26c586f9" providerId="LiveId" clId="{1F1047B7-353E-4D5F-BD1C-2AC2A6DBBBA4}" dt="2026-09-17T07:56:03.593" v="480"/>
+          <pc:sldLayoutMkLst>
+            <pc:docMk/>
+            <pc:sldMasterMk cId="1544047913" sldId="2147483660"/>
+            <pc:sldLayoutMk cId="1309884451" sldId="2147483688"/>
+          </pc:sldLayoutMkLst>
+        </pc:sldLayoutChg>
+        <pc:sldLayoutChg chg="modTransition">
+          <pc:chgData name="Shreena Solia" userId="ce99177b26c586f9" providerId="LiveId" clId="{1F1047B7-353E-4D5F-BD1C-2AC2A6DBBBA4}" dt="2026-09-17T07:56:03.593" v="480"/>
+          <pc:sldLayoutMkLst>
+            <pc:docMk/>
+            <pc:sldMasterMk cId="1544047913" sldId="2147483660"/>
+            <pc:sldLayoutMk cId="1884464865" sldId="2147483690"/>
+          </pc:sldLayoutMkLst>
+        </pc:sldLayoutChg>
+        <pc:sldLayoutChg chg="modTransition">
+          <pc:chgData name="Shreena Solia" userId="ce99177b26c586f9" providerId="LiveId" clId="{1F1047B7-353E-4D5F-BD1C-2AC2A6DBBBA4}" dt="2026-09-17T07:56:03.593" v="480"/>
+          <pc:sldLayoutMkLst>
+            <pc:docMk/>
+            <pc:sldMasterMk cId="1544047913" sldId="2147483660"/>
+            <pc:sldLayoutMk cId="1231035317" sldId="2147483692"/>
+          </pc:sldLayoutMkLst>
+        </pc:sldLayoutChg>
+        <pc:sldLayoutChg chg="modTransition">
+          <pc:chgData name="Shreena Solia" userId="ce99177b26c586f9" providerId="LiveId" clId="{1F1047B7-353E-4D5F-BD1C-2AC2A6DBBBA4}" dt="2026-09-17T07:56:03.593" v="480"/>
+          <pc:sldLayoutMkLst>
+            <pc:docMk/>
+            <pc:sldMasterMk cId="1544047913" sldId="2147483660"/>
+            <pc:sldLayoutMk cId="2199545073" sldId="2147483695"/>
+          </pc:sldLayoutMkLst>
+        </pc:sldLayoutChg>
+        <pc:sldLayoutChg chg="modTransition">
+          <pc:chgData name="Shreena Solia" userId="ce99177b26c586f9" providerId="LiveId" clId="{1F1047B7-353E-4D5F-BD1C-2AC2A6DBBBA4}" dt="2026-09-17T07:56:03.593" v="480"/>
+          <pc:sldLayoutMkLst>
+            <pc:docMk/>
+            <pc:sldMasterMk cId="1544047913" sldId="2147483660"/>
+            <pc:sldLayoutMk cId="4045577202" sldId="2147483698"/>
+          </pc:sldLayoutMkLst>
+        </pc:sldLayoutChg>
+        <pc:sldLayoutChg chg="modTransition">
+          <pc:chgData name="Shreena Solia" userId="ce99177b26c586f9" providerId="LiveId" clId="{1F1047B7-353E-4D5F-BD1C-2AC2A6DBBBA4}" dt="2026-09-17T07:56:03.593" v="480"/>
+          <pc:sldLayoutMkLst>
+            <pc:docMk/>
+            <pc:sldMasterMk cId="1544047913" sldId="2147483660"/>
+            <pc:sldLayoutMk cId="3745439134" sldId="2147483699"/>
+          </pc:sldLayoutMkLst>
+        </pc:sldLayoutChg>
+        <pc:sldLayoutChg chg="modTransition">
+          <pc:chgData name="Shreena Solia" userId="ce99177b26c586f9" providerId="LiveId" clId="{1F1047B7-353E-4D5F-BD1C-2AC2A6DBBBA4}" dt="2026-09-17T07:56:03.593" v="480"/>
+          <pc:sldLayoutMkLst>
+            <pc:docMk/>
+            <pc:sldMasterMk cId="1544047913" sldId="2147483660"/>
+            <pc:sldLayoutMk cId="4268806401" sldId="2147483700"/>
+          </pc:sldLayoutMkLst>
+        </pc:sldLayoutChg>
+        <pc:sldLayoutChg chg="modTransition">
+          <pc:chgData name="Shreena Solia" userId="ce99177b26c586f9" providerId="LiveId" clId="{1F1047B7-353E-4D5F-BD1C-2AC2A6DBBBA4}" dt="2026-09-17T07:56:03.593" v="480"/>
+          <pc:sldLayoutMkLst>
+            <pc:docMk/>
+            <pc:sldMasterMk cId="1544047913" sldId="2147483660"/>
+            <pc:sldLayoutMk cId="4033652303" sldId="2147483701"/>
+          </pc:sldLayoutMkLst>
+        </pc:sldLayoutChg>
+        <pc:sldLayoutChg chg="modTransition">
+          <pc:chgData name="Shreena Solia" userId="ce99177b26c586f9" providerId="LiveId" clId="{1F1047B7-353E-4D5F-BD1C-2AC2A6DBBBA4}" dt="2026-09-17T07:56:03.593" v="480"/>
+          <pc:sldLayoutMkLst>
+            <pc:docMk/>
+            <pc:sldMasterMk cId="1544047913" sldId="2147483660"/>
+            <pc:sldLayoutMk cId="2003226232" sldId="2147483702"/>
+          </pc:sldLayoutMkLst>
+        </pc:sldLayoutChg>
+        <pc:sldLayoutChg chg="modTransition">
+          <pc:chgData name="Shreena Solia" userId="ce99177b26c586f9" providerId="LiveId" clId="{1F1047B7-353E-4D5F-BD1C-2AC2A6DBBBA4}" dt="2026-09-17T07:56:03.593" v="480"/>
+          <pc:sldLayoutMkLst>
+            <pc:docMk/>
+            <pc:sldMasterMk cId="1544047913" sldId="2147483660"/>
+            <pc:sldLayoutMk cId="333197987" sldId="2147483704"/>
+          </pc:sldLayoutMkLst>
+        </pc:sldLayoutChg>
+      </pc:sldMasterChg>
     </pc:docChg>
   </pc:docChgLst>
 </pc:chgInfo>
@@ -674,7 +709,7 @@
                   <a:schemeClr val="tx2"/>
                 </a:solidFill>
               </a:rPr>
-              <a:t>9/1/2026</a:t>
+              <a:t>9/17/2026</a:t>
             </a:fld>
             <a:endParaRPr dirty="0">
               <a:solidFill>
@@ -864,7 +899,7 @@
             <a:fld id="{F95CF31C-F757-429C-A789-86504F04C3BE}" type="datetimeFigureOut">
               <a:rPr lang="en-US"/>
               <a:pPr/>
-              <a:t>9/1/2026</a:t>
+              <a:t>9/17/2026</a:t>
             </a:fld>
             <a:endParaRPr dirty="0"/>
           </a:p>
@@ -2381,14 +2416,14 @@
   <p:clrMapOvr>
     <a:masterClrMapping/>
   </p:clrMapOvr>
-  <mc:AlternateContent xmlns:mc="http://schemas.openxmlformats.org/markup-compatibility/2006" xmlns:p14="http://schemas.microsoft.com/office/powerpoint/2010/main">
-    <mc:Choice Requires="p14">
-      <p:transition spd="med" p14:dur="700">
-        <p:fade/>
+  <mc:AlternateContent xmlns:mc="http://schemas.openxmlformats.org/markup-compatibility/2006">
+    <mc:Choice xmlns:p14="http://schemas.microsoft.com/office/powerpoint/2010/main" Requires="p14">
+      <p:transition spd="slow" p14:dur="4000">
+        <p14:vortex dir="r"/>
       </p:transition>
     </mc:Choice>
-    <mc:Fallback xmlns="">
-      <p:transition spd="med">
+    <mc:Fallback>
+      <p:transition spd="slow">
         <p:fade/>
       </p:transition>
     </mc:Fallback>
@@ -3334,14 +3369,14 @@
   <p:clrMapOvr>
     <a:masterClrMapping/>
   </p:clrMapOvr>
-  <mc:AlternateContent xmlns:mc="http://schemas.openxmlformats.org/markup-compatibility/2006" xmlns:p14="http://schemas.microsoft.com/office/powerpoint/2010/main">
-    <mc:Choice Requires="p14">
-      <p:transition spd="med" p14:dur="700">
-        <p:fade/>
+  <mc:AlternateContent xmlns:mc="http://schemas.openxmlformats.org/markup-compatibility/2006">
+    <mc:Choice xmlns:p14="http://schemas.microsoft.com/office/powerpoint/2010/main" Requires="p14">
+      <p:transition spd="slow" p14:dur="4000">
+        <p14:vortex dir="r"/>
       </p:transition>
     </mc:Choice>
-    <mc:Fallback xmlns="">
-      <p:transition spd="med">
+    <mc:Fallback>
+      <p:transition spd="slow">
         <p:fade/>
       </p:transition>
     </mc:Fallback>
@@ -4335,14 +4370,14 @@
   <p:clrMapOvr>
     <a:masterClrMapping/>
   </p:clrMapOvr>
-  <mc:AlternateContent xmlns:mc="http://schemas.openxmlformats.org/markup-compatibility/2006" xmlns:p14="http://schemas.microsoft.com/office/powerpoint/2010/main">
-    <mc:Choice Requires="p14">
-      <p:transition spd="med" p14:dur="700">
-        <p:fade/>
+  <mc:AlternateContent xmlns:mc="http://schemas.openxmlformats.org/markup-compatibility/2006">
+    <mc:Choice xmlns:p14="http://schemas.microsoft.com/office/powerpoint/2010/main" Requires="p14">
+      <p:transition spd="slow" p14:dur="4000">
+        <p14:vortex dir="r"/>
       </p:transition>
     </mc:Choice>
-    <mc:Fallback xmlns="">
-      <p:transition spd="med">
+    <mc:Fallback>
+      <p:transition spd="slow">
         <p:fade/>
       </p:transition>
     </mc:Fallback>
@@ -5088,14 +5123,14 @@
   <p:clrMapOvr>
     <a:masterClrMapping/>
   </p:clrMapOvr>
-  <mc:AlternateContent xmlns:mc="http://schemas.openxmlformats.org/markup-compatibility/2006" xmlns:p14="http://schemas.microsoft.com/office/powerpoint/2010/main">
-    <mc:Choice Requires="p14">
-      <p:transition spd="med" p14:dur="700">
-        <p:fade/>
+  <mc:AlternateContent xmlns:mc="http://schemas.openxmlformats.org/markup-compatibility/2006">
+    <mc:Choice xmlns:p14="http://schemas.microsoft.com/office/powerpoint/2010/main" Requires="p14">
+      <p:transition spd="slow" p14:dur="4000">
+        <p14:vortex dir="r"/>
       </p:transition>
     </mc:Choice>
-    <mc:Fallback xmlns="">
-      <p:transition spd="med">
+    <mc:Fallback>
+      <p:transition spd="slow">
         <p:fade/>
       </p:transition>
     </mc:Fallback>
@@ -5866,14 +5901,14 @@
   <p:clrMapOvr>
     <a:masterClrMapping/>
   </p:clrMapOvr>
-  <mc:AlternateContent xmlns:mc="http://schemas.openxmlformats.org/markup-compatibility/2006" xmlns:p14="http://schemas.microsoft.com/office/powerpoint/2010/main">
-    <mc:Choice Requires="p14">
-      <p:transition spd="med" p14:dur="700">
-        <p:fade/>
+  <mc:AlternateContent xmlns:mc="http://schemas.openxmlformats.org/markup-compatibility/2006">
+    <mc:Choice xmlns:p14="http://schemas.microsoft.com/office/powerpoint/2010/main" Requires="p14">
+      <p:transition spd="slow" p14:dur="4000">
+        <p14:vortex dir="r"/>
       </p:transition>
     </mc:Choice>
-    <mc:Fallback xmlns="">
-      <p:transition spd="med">
+    <mc:Fallback>
+      <p:transition spd="slow">
         <p:fade/>
       </p:transition>
     </mc:Fallback>
@@ -6881,14 +6916,14 @@
   <p:clrMapOvr>
     <a:masterClrMapping/>
   </p:clrMapOvr>
-  <mc:AlternateContent xmlns:mc="http://schemas.openxmlformats.org/markup-compatibility/2006" xmlns:p14="http://schemas.microsoft.com/office/powerpoint/2010/main">
-    <mc:Choice Requires="p14">
-      <p:transition spd="med" p14:dur="700">
-        <p:fade/>
+  <mc:AlternateContent xmlns:mc="http://schemas.openxmlformats.org/markup-compatibility/2006">
+    <mc:Choice xmlns:p14="http://schemas.microsoft.com/office/powerpoint/2010/main" Requires="p14">
+      <p:transition spd="slow" p14:dur="4000">
+        <p14:vortex dir="r"/>
       </p:transition>
     </mc:Choice>
-    <mc:Fallback xmlns="">
-      <p:transition spd="med">
+    <mc:Fallback>
+      <p:transition spd="slow">
         <p:fade/>
       </p:transition>
     </mc:Fallback>
@@ -7820,14 +7855,14 @@
   <p:clrMapOvr>
     <a:masterClrMapping/>
   </p:clrMapOvr>
-  <mc:AlternateContent xmlns:mc="http://schemas.openxmlformats.org/markup-compatibility/2006" xmlns:p14="http://schemas.microsoft.com/office/powerpoint/2010/main">
-    <mc:Choice Requires="p14">
-      <p:transition spd="med" p14:dur="700">
-        <p:fade/>
+  <mc:AlternateContent xmlns:mc="http://schemas.openxmlformats.org/markup-compatibility/2006">
+    <mc:Choice xmlns:p14="http://schemas.microsoft.com/office/powerpoint/2010/main" Requires="p14">
+      <p:transition spd="slow" p14:dur="4000">
+        <p14:vortex dir="r"/>
       </p:transition>
     </mc:Choice>
-    <mc:Fallback xmlns="">
-      <p:transition spd="med">
+    <mc:Fallback>
+      <p:transition spd="slow">
         <p:fade/>
       </p:transition>
     </mc:Fallback>
@@ -8891,14 +8926,14 @@
   <p:clrMapOvr>
     <a:masterClrMapping/>
   </p:clrMapOvr>
-  <mc:AlternateContent xmlns:mc="http://schemas.openxmlformats.org/markup-compatibility/2006" xmlns:p14="http://schemas.microsoft.com/office/powerpoint/2010/main">
-    <mc:Choice Requires="p14">
-      <p:transition spd="med" p14:dur="700">
-        <p:fade/>
+  <mc:AlternateContent xmlns:mc="http://schemas.openxmlformats.org/markup-compatibility/2006">
+    <mc:Choice xmlns:p14="http://schemas.microsoft.com/office/powerpoint/2010/main" Requires="p14">
+      <p:transition spd="slow" p14:dur="4000">
+        <p14:vortex dir="r"/>
       </p:transition>
     </mc:Choice>
-    <mc:Fallback xmlns="">
-      <p:transition spd="med">
+    <mc:Fallback>
+      <p:transition spd="slow">
         <p:fade/>
       </p:transition>
     </mc:Fallback>
@@ -9826,14 +9861,14 @@
   <p:clrMapOvr>
     <a:masterClrMapping/>
   </p:clrMapOvr>
-  <mc:AlternateContent xmlns:mc="http://schemas.openxmlformats.org/markup-compatibility/2006" xmlns:p14="http://schemas.microsoft.com/office/powerpoint/2010/main">
-    <mc:Choice Requires="p14">
-      <p:transition spd="med" p14:dur="700">
-        <p:fade/>
+  <mc:AlternateContent xmlns:mc="http://schemas.openxmlformats.org/markup-compatibility/2006">
+    <mc:Choice xmlns:p14="http://schemas.microsoft.com/office/powerpoint/2010/main" Requires="p14">
+      <p:transition spd="slow" p14:dur="4000">
+        <p14:vortex dir="r"/>
       </p:transition>
     </mc:Choice>
-    <mc:Fallback xmlns="">
-      <p:transition spd="med">
+    <mc:Fallback>
+      <p:transition spd="slow">
         <p:fade/>
       </p:transition>
     </mc:Fallback>
@@ -10915,14 +10950,14 @@
   <p:clrMapOvr>
     <a:masterClrMapping/>
   </p:clrMapOvr>
-  <mc:AlternateContent xmlns:mc="http://schemas.openxmlformats.org/markup-compatibility/2006" xmlns:p14="http://schemas.microsoft.com/office/powerpoint/2010/main">
-    <mc:Choice Requires="p14">
-      <p:transition spd="med" p14:dur="700">
-        <p:fade/>
+  <mc:AlternateContent xmlns:mc="http://schemas.openxmlformats.org/markup-compatibility/2006">
+    <mc:Choice xmlns:p14="http://schemas.microsoft.com/office/powerpoint/2010/main" Requires="p14">
+      <p:transition spd="slow" p14:dur="4000">
+        <p14:vortex dir="r"/>
       </p:transition>
     </mc:Choice>
-    <mc:Fallback xmlns="">
-      <p:transition spd="med">
+    <mc:Fallback>
+      <p:transition spd="slow">
         <p:fade/>
       </p:transition>
     </mc:Fallback>
@@ -11912,14 +11947,14 @@
   <p:clrMapOvr>
     <a:masterClrMapping/>
   </p:clrMapOvr>
-  <mc:AlternateContent xmlns:mc="http://schemas.openxmlformats.org/markup-compatibility/2006" xmlns:p14="http://schemas.microsoft.com/office/powerpoint/2010/main">
-    <mc:Choice Requires="p14">
-      <p:transition spd="med" p14:dur="700">
-        <p:fade/>
+  <mc:AlternateContent xmlns:mc="http://schemas.openxmlformats.org/markup-compatibility/2006">
+    <mc:Choice xmlns:p14="http://schemas.microsoft.com/office/powerpoint/2010/main" Requires="p14">
+      <p:transition spd="slow" p14:dur="4000">
+        <p14:vortex dir="r"/>
       </p:transition>
     </mc:Choice>
-    <mc:Fallback xmlns="">
-      <p:transition spd="med">
+    <mc:Fallback>
+      <p:transition spd="slow">
         <p:fade/>
       </p:transition>
     </mc:Fallback>
@@ -12842,14 +12877,14 @@
   <p:clrMapOvr>
     <a:masterClrMapping/>
   </p:clrMapOvr>
-  <mc:AlternateContent xmlns:mc="http://schemas.openxmlformats.org/markup-compatibility/2006" xmlns:p14="http://schemas.microsoft.com/office/powerpoint/2010/main">
-    <mc:Choice Requires="p14">
-      <p:transition spd="med" p14:dur="700">
-        <p:fade/>
+  <mc:AlternateContent xmlns:mc="http://schemas.openxmlformats.org/markup-compatibility/2006">
+    <mc:Choice xmlns:p14="http://schemas.microsoft.com/office/powerpoint/2010/main" Requires="p14">
+      <p:transition spd="slow" p14:dur="4000">
+        <p14:vortex dir="r"/>
       </p:transition>
     </mc:Choice>
-    <mc:Fallback xmlns="">
-      <p:transition spd="med">
+    <mc:Fallback>
+      <p:transition spd="slow">
         <p:fade/>
       </p:transition>
     </mc:Fallback>
@@ -13522,14 +13557,14 @@
   <p:clrMapOvr>
     <a:masterClrMapping/>
   </p:clrMapOvr>
-  <mc:AlternateContent xmlns:mc="http://schemas.openxmlformats.org/markup-compatibility/2006" xmlns:p14="http://schemas.microsoft.com/office/powerpoint/2010/main">
-    <mc:Choice Requires="p14">
-      <p:transition spd="med" p14:dur="700">
-        <p:fade/>
+  <mc:AlternateContent xmlns:mc="http://schemas.openxmlformats.org/markup-compatibility/2006">
+    <mc:Choice xmlns:p14="http://schemas.microsoft.com/office/powerpoint/2010/main" Requires="p14">
+      <p:transition spd="slow" p14:dur="4000">
+        <p14:vortex dir="r"/>
       </p:transition>
     </mc:Choice>
-    <mc:Fallback xmlns="">
-      <p:transition spd="med">
+    <mc:Fallback>
+      <p:transition spd="slow">
         <p:fade/>
       </p:transition>
     </mc:Fallback>
@@ -13791,14 +13826,14 @@
     <p:sldLayoutId id="2147483699" r:id="rId12"/>
     <p:sldLayoutId id="2147483704" r:id="rId13"/>
   </p:sldLayoutIdLst>
-  <mc:AlternateContent xmlns:mc="http://schemas.openxmlformats.org/markup-compatibility/2006" xmlns:p14="http://schemas.microsoft.com/office/powerpoint/2010/main">
-    <mc:Choice Requires="p14">
-      <p:transition spd="med" p14:dur="700">
-        <p:fade/>
+  <mc:AlternateContent xmlns:mc="http://schemas.openxmlformats.org/markup-compatibility/2006">
+    <mc:Choice xmlns:p14="http://schemas.microsoft.com/office/powerpoint/2010/main" Requires="p14">
+      <p:transition spd="slow" p14:dur="4000">
+        <p14:vortex dir="r"/>
       </p:transition>
     </mc:Choice>
-    <mc:Fallback xmlns="">
-      <p:transition spd="med">
+    <mc:Fallback>
+      <p:transition spd="slow">
         <p:fade/>
       </p:transition>
     </mc:Fallback>
@@ -14197,12 +14232,16 @@
   <p:clrMapOvr>
     <a:masterClrMapping/>
   </p:clrMapOvr>
-  <mc:AlternateContent xmlns:mc="http://schemas.openxmlformats.org/markup-compatibility/2006" xmlns:p14="http://schemas.microsoft.com/office/powerpoint/2010/main">
-    <mc:Choice Requires="p14">
-      <p:transition p14:dur="0"/>
+  <mc:AlternateContent xmlns:mc="http://schemas.openxmlformats.org/markup-compatibility/2006">
+    <mc:Choice xmlns:p14="http://schemas.microsoft.com/office/powerpoint/2010/main" Requires="p14">
+      <p:transition spd="slow" p14:dur="4000">
+        <p14:vortex dir="r"/>
+      </p:transition>
     </mc:Choice>
-    <mc:Fallback xmlns="">
-      <p:transition/>
+    <mc:Fallback>
+      <p:transition spd="slow">
+        <p:fade/>
+      </p:transition>
     </mc:Fallback>
   </mc:AlternateContent>
 </p:sld>
@@ -14277,12 +14316,16 @@
   <p:clrMapOvr>
     <a:masterClrMapping/>
   </p:clrMapOvr>
-  <mc:AlternateContent xmlns:mc="http://schemas.openxmlformats.org/markup-compatibility/2006" xmlns:p14="http://schemas.microsoft.com/office/powerpoint/2010/main">
-    <mc:Choice Requires="p14">
-      <p:transition p14:dur="0"/>
+  <mc:AlternateContent xmlns:mc="http://schemas.openxmlformats.org/markup-compatibility/2006">
+    <mc:Choice xmlns:p14="http://schemas.microsoft.com/office/powerpoint/2010/main" Requires="p14">
+      <p:transition spd="slow" p14:dur="4000">
+        <p14:vortex dir="r"/>
+      </p:transition>
     </mc:Choice>
-    <mc:Fallback xmlns="">
-      <p:transition/>
+    <mc:Fallback>
+      <p:transition spd="slow">
+        <p:fade/>
+      </p:transition>
     </mc:Fallback>
   </mc:AlternateContent>
 </p:sld>
@@ -14424,12 +14467,16 @@
   <p:clrMapOvr>
     <a:masterClrMapping/>
   </p:clrMapOvr>
-  <mc:AlternateContent xmlns:mc="http://schemas.openxmlformats.org/markup-compatibility/2006" xmlns:p14="http://schemas.microsoft.com/office/powerpoint/2010/main">
-    <mc:Choice Requires="p14">
-      <p:transition p14:dur="0"/>
+  <mc:AlternateContent xmlns:mc="http://schemas.openxmlformats.org/markup-compatibility/2006">
+    <mc:Choice xmlns:p14="http://schemas.microsoft.com/office/powerpoint/2010/main" Requires="p14">
+      <p:transition spd="slow" p14:dur="4000">
+        <p14:vortex dir="r"/>
+      </p:transition>
     </mc:Choice>
-    <mc:Fallback xmlns="">
-      <p:transition/>
+    <mc:Fallback>
+      <p:transition spd="slow">
+        <p:fade/>
+      </p:transition>
     </mc:Fallback>
   </mc:AlternateContent>
 </p:sld>
@@ -14604,12 +14651,16 @@
   <p:clrMapOvr>
     <a:masterClrMapping/>
   </p:clrMapOvr>
-  <mc:AlternateContent xmlns:mc="http://schemas.openxmlformats.org/markup-compatibility/2006" xmlns:p14="http://schemas.microsoft.com/office/powerpoint/2010/main">
-    <mc:Choice Requires="p14">
-      <p:transition p14:dur="0"/>
+  <mc:AlternateContent xmlns:mc="http://schemas.openxmlformats.org/markup-compatibility/2006">
+    <mc:Choice xmlns:p14="http://schemas.microsoft.com/office/powerpoint/2010/main" Requires="p14">
+      <p:transition spd="slow" p14:dur="4000">
+        <p14:vortex dir="r"/>
+      </p:transition>
     </mc:Choice>
-    <mc:Fallback xmlns="">
-      <p:transition/>
+    <mc:Fallback>
+      <p:transition spd="slow">
+        <p:fade/>
+      </p:transition>
     </mc:Fallback>
   </mc:AlternateContent>
 </p:sld>
@@ -14677,12 +14728,16 @@
   <p:clrMapOvr>
     <a:masterClrMapping/>
   </p:clrMapOvr>
-  <mc:AlternateContent xmlns:mc="http://schemas.openxmlformats.org/markup-compatibility/2006" xmlns:p14="http://schemas.microsoft.com/office/powerpoint/2010/main">
-    <mc:Choice Requires="p14">
-      <p:transition p14:dur="0"/>
+  <mc:AlternateContent xmlns:mc="http://schemas.openxmlformats.org/markup-compatibility/2006">
+    <mc:Choice xmlns:p14="http://schemas.microsoft.com/office/powerpoint/2010/main" Requires="p14">
+      <p:transition spd="slow" p14:dur="4000">
+        <p14:vortex dir="r"/>
+      </p:transition>
     </mc:Choice>
-    <mc:Fallback xmlns="">
-      <p:transition/>
+    <mc:Fallback>
+      <p:transition spd="slow">
+        <p:fade/>
+      </p:transition>
     </mc:Fallback>
   </mc:AlternateContent>
 </p:sld>
@@ -15048,12 +15103,16 @@
   <p:clrMapOvr>
     <a:masterClrMapping/>
   </p:clrMapOvr>
-  <mc:AlternateContent xmlns:mc="http://schemas.openxmlformats.org/markup-compatibility/2006" xmlns:p14="http://schemas.microsoft.com/office/powerpoint/2010/main">
-    <mc:Choice Requires="p14">
-      <p:transition p14:dur="0"/>
+  <mc:AlternateContent xmlns:mc="http://schemas.openxmlformats.org/markup-compatibility/2006">
+    <mc:Choice xmlns:p14="http://schemas.microsoft.com/office/powerpoint/2010/main" Requires="p14">
+      <p:transition spd="slow" p14:dur="4000">
+        <p14:vortex dir="r"/>
+      </p:transition>
     </mc:Choice>
-    <mc:Fallback xmlns="">
-      <p:transition/>
+    <mc:Fallback>
+      <p:transition spd="slow">
+        <p:fade/>
+      </p:transition>
     </mc:Fallback>
   </mc:AlternateContent>
 </p:sld>
@@ -15320,12 +15379,16 @@
   <p:clrMapOvr>
     <a:masterClrMapping/>
   </p:clrMapOvr>
-  <mc:AlternateContent xmlns:mc="http://schemas.openxmlformats.org/markup-compatibility/2006" xmlns:p14="http://schemas.microsoft.com/office/powerpoint/2010/main">
-    <mc:Choice Requires="p14">
-      <p:transition p14:dur="0"/>
+  <mc:AlternateContent xmlns:mc="http://schemas.openxmlformats.org/markup-compatibility/2006">
+    <mc:Choice xmlns:p14="http://schemas.microsoft.com/office/powerpoint/2010/main" Requires="p14">
+      <p:transition spd="slow" p14:dur="4000">
+        <p14:vortex dir="r"/>
+      </p:transition>
     </mc:Choice>
-    <mc:Fallback xmlns="">
-      <p:transition/>
+    <mc:Fallback>
+      <p:transition spd="slow">
+        <p:fade/>
+      </p:transition>
     </mc:Fallback>
   </mc:AlternateContent>
 </p:sld>
@@ -15561,12 +15624,16 @@
   <p:clrMapOvr>
     <a:masterClrMapping/>
   </p:clrMapOvr>
-  <mc:AlternateContent xmlns:mc="http://schemas.openxmlformats.org/markup-compatibility/2006" xmlns:p14="http://schemas.microsoft.com/office/powerpoint/2010/main">
-    <mc:Choice Requires="p14">
-      <p:transition p14:dur="0"/>
+  <mc:AlternateContent xmlns:mc="http://schemas.openxmlformats.org/markup-compatibility/2006">
+    <mc:Choice xmlns:p14="http://schemas.microsoft.com/office/powerpoint/2010/main" Requires="p14">
+      <p:transition spd="slow" p14:dur="4000">
+        <p14:vortex dir="r"/>
+      </p:transition>
     </mc:Choice>
-    <mc:Fallback xmlns="">
-      <p:transition/>
+    <mc:Fallback>
+      <p:transition spd="slow">
+        <p:fade/>
+      </p:transition>
     </mc:Fallback>
   </mc:AlternateContent>
 </p:sld>
@@ -15801,12 +15868,16 @@
   <p:clrMapOvr>
     <a:masterClrMapping/>
   </p:clrMapOvr>
-  <mc:AlternateContent xmlns:mc="http://schemas.openxmlformats.org/markup-compatibility/2006" xmlns:p14="http://schemas.microsoft.com/office/powerpoint/2010/main">
-    <mc:Choice Requires="p14">
-      <p:transition p14:dur="0"/>
+  <mc:AlternateContent xmlns:mc="http://schemas.openxmlformats.org/markup-compatibility/2006">
+    <mc:Choice xmlns:p14="http://schemas.microsoft.com/office/powerpoint/2010/main" Requires="p14">
+      <p:transition spd="slow" p14:dur="4000">
+        <p14:vortex dir="r"/>
+      </p:transition>
     </mc:Choice>
-    <mc:Fallback xmlns="">
-      <p:transition/>
+    <mc:Fallback>
+      <p:transition spd="slow">
+        <p:fade/>
+      </p:transition>
     </mc:Fallback>
   </mc:AlternateContent>
 </p:sld>
@@ -16054,12 +16125,16 @@
   <p:clrMapOvr>
     <a:masterClrMapping/>
   </p:clrMapOvr>
-  <mc:AlternateContent xmlns:mc="http://schemas.openxmlformats.org/markup-compatibility/2006" xmlns:p14="http://schemas.microsoft.com/office/powerpoint/2010/main">
-    <mc:Choice Requires="p14">
-      <p:transition p14:dur="0"/>
+  <mc:AlternateContent xmlns:mc="http://schemas.openxmlformats.org/markup-compatibility/2006">
+    <mc:Choice xmlns:p14="http://schemas.microsoft.com/office/powerpoint/2010/main" Requires="p14">
+      <p:transition spd="slow" p14:dur="4000">
+        <p14:vortex dir="r"/>
+      </p:transition>
     </mc:Choice>
-    <mc:Fallback xmlns="">
-      <p:transition/>
+    <mc:Fallback>
+      <p:transition spd="slow">
+        <p:fade/>
+      </p:transition>
     </mc:Fallback>
   </mc:AlternateContent>
 </p:sld>
@@ -16215,12 +16290,16 @@
   <p:clrMapOvr>
     <a:masterClrMapping/>
   </p:clrMapOvr>
-  <mc:AlternateContent xmlns:mc="http://schemas.openxmlformats.org/markup-compatibility/2006" xmlns:p14="http://schemas.microsoft.com/office/powerpoint/2010/main">
-    <mc:Choice Requires="p14">
-      <p:transition p14:dur="0"/>
+  <mc:AlternateContent xmlns:mc="http://schemas.openxmlformats.org/markup-compatibility/2006">
+    <mc:Choice xmlns:p14="http://schemas.microsoft.com/office/powerpoint/2010/main" Requires="p14">
+      <p:transition spd="slow" p14:dur="4000">
+        <p14:vortex dir="r"/>
+      </p:transition>
     </mc:Choice>
-    <mc:Fallback xmlns="">
-      <p:transition/>
+    <mc:Fallback>
+      <p:transition spd="slow">
+        <p:fade/>
+      </p:transition>
     </mc:Fallback>
   </mc:AlternateContent>
 </p:sld>
@@ -16374,12 +16453,16 @@
   <p:clrMapOvr>
     <a:masterClrMapping/>
   </p:clrMapOvr>
-  <mc:AlternateContent xmlns:mc="http://schemas.openxmlformats.org/markup-compatibility/2006" xmlns:p14="http://schemas.microsoft.com/office/powerpoint/2010/main">
-    <mc:Choice Requires="p14">
-      <p:transition p14:dur="0"/>
+  <mc:AlternateContent xmlns:mc="http://schemas.openxmlformats.org/markup-compatibility/2006">
+    <mc:Choice xmlns:p14="http://schemas.microsoft.com/office/powerpoint/2010/main" Requires="p14">
+      <p:transition spd="slow" p14:dur="4000">
+        <p14:vortex dir="r"/>
+      </p:transition>
     </mc:Choice>
-    <mc:Fallback xmlns="">
-      <p:transition/>
+    <mc:Fallback>
+      <p:transition spd="slow">
+        <p:fade/>
+      </p:transition>
     </mc:Fallback>
   </mc:AlternateContent>
 </p:sld>
@@ -16529,12 +16612,16 @@
   <p:clrMapOvr>
     <a:masterClrMapping/>
   </p:clrMapOvr>
-  <mc:AlternateContent xmlns:mc="http://schemas.openxmlformats.org/markup-compatibility/2006" xmlns:p14="http://schemas.microsoft.com/office/powerpoint/2010/main">
-    <mc:Choice Requires="p14">
-      <p:transition p14:dur="0"/>
+  <mc:AlternateContent xmlns:mc="http://schemas.openxmlformats.org/markup-compatibility/2006">
+    <mc:Choice xmlns:p14="http://schemas.microsoft.com/office/powerpoint/2010/main" Requires="p14">
+      <p:transition spd="slow" p14:dur="4000">
+        <p14:vortex dir="r"/>
+      </p:transition>
     </mc:Choice>
-    <mc:Fallback xmlns="">
-      <p:transition/>
+    <mc:Fallback>
+      <p:transition spd="slow">
+        <p:fade/>
+      </p:transition>
     </mc:Fallback>
   </mc:AlternateContent>
 </p:sld>
@@ -17290,12 +17377,23 @@
 </file>
 
 <file path=customXml/item1.xml><?xml version="1.0" encoding="utf-8"?>
-<?mso-contentType ?>
-<FormTemplates xmlns="http://schemas.microsoft.com/sharepoint/v3/contenttype/forms">
-  <Display>DocumentLibraryForm</Display>
-  <Edit>DocumentLibraryForm</Edit>
-  <New>DocumentLibraryForm</New>
-</FormTemplates>
+<p:properties xmlns:p="http://schemas.microsoft.com/office/2006/metadata/properties" xmlns:xsi="http://www.w3.org/2001/XMLSchema-instance" xmlns:pc="http://schemas.microsoft.com/office/infopath/2007/PartnerControls">
+  <documentManagement>
+    <_ip_UnifiedCompliancePolicyUIAction xmlns="http://schemas.microsoft.com/sharepoint/v3" xsi:nil="true"/>
+    <Image xmlns="71af3243-3dd4-4a8d-8c0d-dd76da1f02a5">
+      <Url xsi:nil="true"/>
+      <Description xsi:nil="true"/>
+    </Image>
+    <Status xmlns="71af3243-3dd4-4a8d-8c0d-dd76da1f02a5">Not started</Status>
+    <Background xmlns="71af3243-3dd4-4a8d-8c0d-dd76da1f02a5">false</Background>
+    <_ip_UnifiedCompliancePolicyProperties xmlns="http://schemas.microsoft.com/sharepoint/v3" xsi:nil="true"/>
+    <ImageTagsTaxHTField xmlns="71af3243-3dd4-4a8d-8c0d-dd76da1f02a5">
+      <Terms xmlns="http://schemas.microsoft.com/office/infopath/2007/PartnerControls"/>
+    </ImageTagsTaxHTField>
+    <TaxCatchAll xmlns="230e9df3-be65-4c73-a93b-d1236ebd677e" xsi:nil="true"/>
+    <MediaServiceKeyPoints xmlns="71af3243-3dd4-4a8d-8c0d-dd76da1f02a5" xsi:nil="true"/>
+  </documentManagement>
+</p:properties>
 </file>
 
 <file path=customXml/item2.xml><?xml version="1.0" encoding="utf-8"?>
@@ -17611,29 +17709,29 @@
 </file>
 
 <file path=customXml/item3.xml><?xml version="1.0" encoding="utf-8"?>
-<p:properties xmlns:p="http://schemas.microsoft.com/office/2006/metadata/properties" xmlns:xsi="http://www.w3.org/2001/XMLSchema-instance" xmlns:pc="http://schemas.microsoft.com/office/infopath/2007/PartnerControls">
-  <documentManagement>
-    <_ip_UnifiedCompliancePolicyUIAction xmlns="http://schemas.microsoft.com/sharepoint/v3" xsi:nil="true"/>
-    <Image xmlns="71af3243-3dd4-4a8d-8c0d-dd76da1f02a5">
-      <Url xsi:nil="true"/>
-      <Description xsi:nil="true"/>
-    </Image>
-    <Status xmlns="71af3243-3dd4-4a8d-8c0d-dd76da1f02a5">Not started</Status>
-    <Background xmlns="71af3243-3dd4-4a8d-8c0d-dd76da1f02a5">false</Background>
-    <_ip_UnifiedCompliancePolicyProperties xmlns="http://schemas.microsoft.com/sharepoint/v3" xsi:nil="true"/>
-    <ImageTagsTaxHTField xmlns="71af3243-3dd4-4a8d-8c0d-dd76da1f02a5">
-      <Terms xmlns="http://schemas.microsoft.com/office/infopath/2007/PartnerControls"/>
-    </ImageTagsTaxHTField>
-    <TaxCatchAll xmlns="230e9df3-be65-4c73-a93b-d1236ebd677e" xsi:nil="true"/>
-    <MediaServiceKeyPoints xmlns="71af3243-3dd4-4a8d-8c0d-dd76da1f02a5" xsi:nil="true"/>
-  </documentManagement>
-</p:properties>
+<?mso-contentType ?>
+<FormTemplates xmlns="http://schemas.microsoft.com/sharepoint/v3/contenttype/forms">
+  <Display>DocumentLibraryForm</Display>
+  <Edit>DocumentLibraryForm</Edit>
+  <New>DocumentLibraryForm</New>
+</FormTemplates>
 </file>
 
 <file path=customXml/itemProps1.xml><?xml version="1.0" encoding="utf-8"?>
-<ds:datastoreItem xmlns:ds="http://schemas.openxmlformats.org/officeDocument/2006/customXml" ds:itemID="{98BD8C90-A3BA-4A7A-B350-4B9A0D6525A4}">
+<ds:datastoreItem xmlns:ds="http://schemas.openxmlformats.org/officeDocument/2006/customXml" ds:itemID="{C4275B5A-7993-4B5E-9459-F514F3EBE15D}">
   <ds:schemaRefs>
-    <ds:schemaRef ds:uri="http://schemas.microsoft.com/sharepoint/v3/contenttype/forms"/>
+    <ds:schemaRef ds:uri="http://purl.org/dc/dcmitype/"/>
+    <ds:schemaRef ds:uri="http://schemas.microsoft.com/office/2006/documentManagement/types"/>
+    <ds:schemaRef ds:uri="http://purl.org/dc/elements/1.1/"/>
+    <ds:schemaRef ds:uri="230e9df3-be65-4c73-a93b-d1236ebd677e"/>
+    <ds:schemaRef ds:uri="http://schemas.microsoft.com/office/infopath/2007/PartnerControls"/>
+    <ds:schemaRef ds:uri="16c05727-aa75-4e4a-9b5f-8a80a1165891"/>
+    <ds:schemaRef ds:uri="http://schemas.microsoft.com/office/2006/metadata/properties"/>
+    <ds:schemaRef ds:uri="http://schemas.openxmlformats.org/package/2006/metadata/core-properties"/>
+    <ds:schemaRef ds:uri="71af3243-3dd4-4a8d-8c0d-dd76da1f02a5"/>
+    <ds:schemaRef ds:uri="http://schemas.microsoft.com/sharepoint/v3"/>
+    <ds:schemaRef ds:uri="http://www.w3.org/XML/1998/namespace"/>
+    <ds:schemaRef ds:uri="http://purl.org/dc/terms/"/>
   </ds:schemaRefs>
 </ds:datastoreItem>
 </file>
@@ -17660,20 +17758,9 @@
 </file>
 
 <file path=customXml/itemProps3.xml><?xml version="1.0" encoding="utf-8"?>
-<ds:datastoreItem xmlns:ds="http://schemas.openxmlformats.org/officeDocument/2006/customXml" ds:itemID="{C4275B5A-7993-4B5E-9459-F514F3EBE15D}">
+<ds:datastoreItem xmlns:ds="http://schemas.openxmlformats.org/officeDocument/2006/customXml" ds:itemID="{98BD8C90-A3BA-4A7A-B350-4B9A0D6525A4}">
   <ds:schemaRefs>
-    <ds:schemaRef ds:uri="http://purl.org/dc/dcmitype/"/>
-    <ds:schemaRef ds:uri="http://schemas.microsoft.com/office/2006/documentManagement/types"/>
-    <ds:schemaRef ds:uri="http://purl.org/dc/elements/1.1/"/>
-    <ds:schemaRef ds:uri="230e9df3-be65-4c73-a93b-d1236ebd677e"/>
-    <ds:schemaRef ds:uri="http://schemas.microsoft.com/office/infopath/2007/PartnerControls"/>
-    <ds:schemaRef ds:uri="16c05727-aa75-4e4a-9b5f-8a80a1165891"/>
-    <ds:schemaRef ds:uri="http://schemas.microsoft.com/office/2006/metadata/properties"/>
-    <ds:schemaRef ds:uri="http://schemas.openxmlformats.org/package/2006/metadata/core-properties"/>
-    <ds:schemaRef ds:uri="71af3243-3dd4-4a8d-8c0d-dd76da1f02a5"/>
-    <ds:schemaRef ds:uri="http://schemas.microsoft.com/sharepoint/v3"/>
-    <ds:schemaRef ds:uri="http://www.w3.org/XML/1998/namespace"/>
-    <ds:schemaRef ds:uri="http://purl.org/dc/terms/"/>
+    <ds:schemaRef ds:uri="http://schemas.microsoft.com/sharepoint/v3/contenttype/forms"/>
   </ds:schemaRefs>
 </ds:datastoreItem>
 </file>

</xml_diff>